<commit_message>
Polish form demos and fetch form fonts from Google Fonts
</commit_message>
<xml_diff>
--- a/converter/pptx/testdata/form-fixed.pptx
+++ b/converter/pptx/testdata/form-fixed.pptx
@@ -3111,7 +3111,7 @@
             <a:pPr algn="ctr"/>
             <a:r>
               <a:rPr lang="ja-JP" sz="2800" b="1"/>
-              <a:t>明書 Certificate</a:t>
+              <a:t>明細書 Certificate</a:t>
             </a:r>
           </a:p>
         </p:txBody>
@@ -3165,8 +3165,8 @@
           <a:lstStyle/>
           <a:p>
             <a:r>
-              <a:rPr lang="ja-JP" sz="1400" b="1"/>
-              <a:t>日 </a:t>
+              <a:rPr lang="en-US" sz="1400" b="1"/>
+              <a:t>Date </a:t>
             </a:r>
             <a:r>
               <a:rPr lang="en-US" sz="1400"/>
@@ -3389,12 +3389,6 @@
             <a:r>
               <a:rPr lang="en-US" sz="1400"/>
               <a:t>{{missing}}</a:t>
-            </a:r>
-          </a:p>
-          <a:p>
-            <a:r>
-              <a:rPr lang="en-US" sz="1400"/>
-              <a:t>\{{not a tag}}</a:t>
             </a:r>
           </a:p>
         </p:txBody>

</xml_diff>

<commit_message>
Polish form demos and fetch form fonts from Google Fonts (#92)
</commit_message>
<xml_diff>
--- a/converter/pptx/testdata/form-fixed.pptx
+++ b/converter/pptx/testdata/form-fixed.pptx
@@ -3111,7 +3111,7 @@
             <a:pPr algn="ctr"/>
             <a:r>
               <a:rPr lang="ja-JP" sz="2800" b="1"/>
-              <a:t>明書 Certificate</a:t>
+              <a:t>明細書 Certificate</a:t>
             </a:r>
           </a:p>
         </p:txBody>
@@ -3165,8 +3165,8 @@
           <a:lstStyle/>
           <a:p>
             <a:r>
-              <a:rPr lang="ja-JP" sz="1400" b="1"/>
-              <a:t>日 </a:t>
+              <a:rPr lang="en-US" sz="1400" b="1"/>
+              <a:t>Date </a:t>
             </a:r>
             <a:r>
               <a:rPr lang="en-US" sz="1400"/>
@@ -3389,12 +3389,6 @@
             <a:r>
               <a:rPr lang="en-US" sz="1400"/>
               <a:t>{{missing}}</a:t>
-            </a:r>
-          </a:p>
-          <a:p>
-            <a:r>
-              <a:rPr lang="en-US" sz="1400"/>
-              <a:t>\{{not a tag}}</a:t>
             </a:r>
           </a:p>
         </p:txBody>

</xml_diff>